<commit_message>
Show VŠFS as bachelor's degree without year of study
Co-Authored-By: Claude Opus 5.5 <noreply@anthropic.com>
Claude-Session: https://claude.ai/code/session_01VE1bLi5VTBXn7QwuZiU1Kc
</commit_message>
<xml_diff>
--- a/presentation/Kangeldieva_SMM.pptx
+++ b/presentation/Kangeldieva_SMM.pptx
@@ -117,13 +117,13 @@
   <p:extLst>
     <p:ext uri="{521415D9-36F7-43E2-AB2F-B90AF26B5E84}">
       <p14:sectionLst xmlns:p14="http://schemas.microsoft.com/office/powerpoint/2010/main">
-        <p14:section name="Кто я" id="{3b0f085a-60c3-806d-ecd4-5a736dc9e32e}">
+        <p14:section name="Кто я" id="{5db3e0a1-5061-8a1b-b5f7-31df463075d2}">
           <p14:sldIdLst>
             <p14:sldId id="256"/>
             <p14:sldId id="257"/>
           </p14:sldIdLst>
         </p14:section>
-        <p14:section name="Результаты и опыт" id="{10caa4d0-76b4-f832-5b18-15394226d513}">
+        <p14:section name="Результаты и опыт" id="{1cb78063-6c16-c738-397c-1055e8318edd}">
           <p14:sldIdLst>
             <p14:sldId id="258"/>
             <p14:sldId id="259"/>
@@ -132,13 +132,13 @@
             <p14:sldId id="262"/>
           </p14:sldIdLst>
         </p14:section>
-        <p14:section name="Компетенции" id="{2c917604-7dca-07c8-2770-dace02bc54cf}">
+        <p14:section name="Компетенции" id="{8594e18a-eeda-3a08-0421-6302d5e8feaf}">
           <p14:sldIdLst>
             <p14:sldId id="263"/>
             <p14:sldId id="264"/>
           </p14:sldIdLst>
         </p14:section>
-        <p14:section name="План и контакты" id="{46fafe8e-e465-fab8-e327-3401ecfdd404}">
+        <p14:section name="План и контакты" id="{4b721af8-d569-ef56-1afa-65110453f581}">
           <p14:sldIdLst>
             <p14:sldId id="265"/>
             <p14:sldId id="266"/>
@@ -4125,7 +4125,7 @@
                   <a:schemeClr val="tx2"/>
                 </a:solidFill>
               </a:rPr>
-              <a:t>Marketingová komunikace, 1-й курс, Прага</a:t>
+              <a:t>Бакалавриат</a:t>
             </a:r>
             <a:endParaRPr lang="en-US" sz="1600" dirty="0"/>
           </a:p>
@@ -4161,7 +4161,7 @@
                   <a:schemeClr val="tx2"/>
                 </a:solidFill>
               </a:rPr>
-              <a:t>Площадки: Instagram, TikTok, Facebook. Рынки: Центральная Азия, США. Сейчас учусь маркетинговой коммуникации в Праге.</a:t>
+              <a:t>Площадки: Instagram, TikTok, Facebook. Рынки: Центральная Азия, США. Живу в Праге.</a:t>
             </a:r>
             <a:endParaRPr lang="en-US" sz="1600" dirty="0"/>
           </a:p>

</xml_diff>

<commit_message>
Replace Innovat with DemirBank; give Booking Lane its own slide
Co-Authored-By: Claude Opus 5.5 <noreply@anthropic.com>
Claude-Session: https://claude.ai/code/session_01VE1bLi5VTBXn7QwuZiU1Kc
</commit_message>
<xml_diff>
--- a/presentation/Kangeldieva_SMM.pptx
+++ b/presentation/Kangeldieva_SMM.pptx
@@ -117,13 +117,13 @@
   <p:extLst>
     <p:ext uri="{521415D9-36F7-43E2-AB2F-B90AF26B5E84}">
       <p14:sectionLst xmlns:p14="http://schemas.microsoft.com/office/powerpoint/2010/main">
-        <p14:section name="Кто я" id="{5db3e0a1-5061-8a1b-b5f7-31df463075d2}">
+        <p14:section name="Кто я" id="{58d39aa0-56f7-bef9-1af6-a555b6d126b5}">
           <p14:sldIdLst>
             <p14:sldId id="256"/>
             <p14:sldId id="257"/>
           </p14:sldIdLst>
         </p14:section>
-        <p14:section name="Результаты и опыт" id="{1cb78063-6c16-c738-397c-1055e8318edd}">
+        <p14:section name="Результаты и опыт" id="{e7890bd4-9617-996a-825a-42f69a9d7fe7}">
           <p14:sldIdLst>
             <p14:sldId id="258"/>
             <p14:sldId id="259"/>
@@ -132,13 +132,13 @@
             <p14:sldId id="262"/>
           </p14:sldIdLst>
         </p14:section>
-        <p14:section name="Компетенции" id="{8594e18a-eeda-3a08-0421-6302d5e8feaf}">
+        <p14:section name="Компетенции" id="{1b198af2-1d02-1573-2361-c3bae945c9e3}">
           <p14:sldIdLst>
             <p14:sldId id="263"/>
             <p14:sldId id="264"/>
           </p14:sldIdLst>
         </p14:section>
-        <p14:section name="План и контакты" id="{4b721af8-d569-ef56-1afa-65110453f581}">
+        <p14:section name="План и контакты" id="{85fb757b-bda2-e014-4280-bbf3648f365a}">
           <p14:sldIdLst>
             <p14:sldId id="265"/>
             <p14:sldId id="266"/>
@@ -2949,7 +2949,7 @@
       </p:sp>
       <p:sp>
         <p:nvSpPr>
-          <p:cNvPr id="4" name="card-149"/>
+          <p:cNvPr id="4" name="card-142"/>
           <p:cNvSpPr/>
           <p:nvPr/>
         </p:nvSpPr>
@@ -2976,7 +2976,7 @@
       </p:sp>
       <p:sp>
         <p:nvSpPr>
-          <p:cNvPr id="5" name="text-150"/>
+          <p:cNvPr id="5" name="text-143"/>
           <p:cNvSpPr txBox="1"/>
           <p:nvPr/>
         </p:nvSpPr>
@@ -3012,7 +3012,7 @@
       </p:sp>
       <p:sp>
         <p:nvSpPr>
-          <p:cNvPr id="6" name="text-151"/>
+          <p:cNvPr id="6" name="text-144"/>
           <p:cNvSpPr txBox="1"/>
           <p:nvPr/>
         </p:nvSpPr>
@@ -3048,7 +3048,7 @@
       </p:sp>
       <p:sp>
         <p:nvSpPr>
-          <p:cNvPr id="7" name="text-152"/>
+          <p:cNvPr id="7" name="text-145"/>
           <p:cNvSpPr txBox="1"/>
           <p:nvPr/>
         </p:nvSpPr>
@@ -3084,7 +3084,7 @@
       </p:sp>
       <p:sp>
         <p:nvSpPr>
-          <p:cNvPr id="8" name="card-153"/>
+          <p:cNvPr id="8" name="card-146"/>
           <p:cNvSpPr/>
           <p:nvPr/>
         </p:nvSpPr>
@@ -3111,7 +3111,7 @@
       </p:sp>
       <p:sp>
         <p:nvSpPr>
-          <p:cNvPr id="9" name="text-154"/>
+          <p:cNvPr id="9" name="text-147"/>
           <p:cNvSpPr txBox="1"/>
           <p:nvPr/>
         </p:nvSpPr>
@@ -3147,7 +3147,7 @@
       </p:sp>
       <p:sp>
         <p:nvSpPr>
-          <p:cNvPr id="10" name="text-155"/>
+          <p:cNvPr id="10" name="text-148"/>
           <p:cNvSpPr txBox="1"/>
           <p:nvPr/>
         </p:nvSpPr>
@@ -3183,7 +3183,7 @@
       </p:sp>
       <p:sp>
         <p:nvSpPr>
-          <p:cNvPr id="11" name="text-156"/>
+          <p:cNvPr id="11" name="text-149"/>
           <p:cNvSpPr txBox="1"/>
           <p:nvPr/>
         </p:nvSpPr>
@@ -3219,7 +3219,7 @@
       </p:sp>
       <p:sp>
         <p:nvSpPr>
-          <p:cNvPr id="12" name="card-157"/>
+          <p:cNvPr id="12" name="card-150"/>
           <p:cNvSpPr/>
           <p:nvPr/>
         </p:nvSpPr>
@@ -3246,7 +3246,7 @@
       </p:sp>
       <p:sp>
         <p:nvSpPr>
-          <p:cNvPr id="13" name="text-158"/>
+          <p:cNvPr id="13" name="text-151"/>
           <p:cNvSpPr txBox="1"/>
           <p:nvPr/>
         </p:nvSpPr>
@@ -3282,7 +3282,7 @@
       </p:sp>
       <p:sp>
         <p:nvSpPr>
-          <p:cNvPr id="14" name="text-159"/>
+          <p:cNvPr id="14" name="text-152"/>
           <p:cNvSpPr txBox="1"/>
           <p:nvPr/>
         </p:nvSpPr>
@@ -3318,7 +3318,7 @@
       </p:sp>
       <p:sp>
         <p:nvSpPr>
-          <p:cNvPr id="15" name="text-160"/>
+          <p:cNvPr id="15" name="text-153"/>
           <p:cNvSpPr txBox="1"/>
           <p:nvPr/>
         </p:nvSpPr>
@@ -3354,7 +3354,7 @@
       </p:sp>
       <p:sp>
         <p:nvSpPr>
-          <p:cNvPr id="16" name="text-161"/>
+          <p:cNvPr id="16" name="text-154"/>
           <p:cNvSpPr txBox="1"/>
           <p:nvPr/>
         </p:nvSpPr>
@@ -3460,7 +3460,7 @@
       </p:grpSpPr>
       <p:sp>
         <p:nvSpPr>
-          <p:cNvPr id="2" name="text-162"/>
+          <p:cNvPr id="2" name="text-155"/>
           <p:cNvSpPr txBox="1"/>
           <p:nvPr/>
         </p:nvSpPr>
@@ -3496,7 +3496,7 @@
       </p:sp>
       <p:sp>
         <p:nvSpPr>
-          <p:cNvPr id="3" name="text-163"/>
+          <p:cNvPr id="3" name="text-156"/>
           <p:cNvSpPr txBox="1"/>
           <p:nvPr/>
         </p:nvSpPr>
@@ -3552,7 +3552,7 @@
       </p:sp>
       <p:sp>
         <p:nvSpPr>
-          <p:cNvPr id="4" name="pill-164"/>
+          <p:cNvPr id="4" name="pill-157"/>
           <p:cNvSpPr/>
           <p:nvPr/>
         </p:nvSpPr>
@@ -3574,7 +3574,7 @@
       </p:sp>
       <p:sp>
         <p:nvSpPr>
-          <p:cNvPr id="5" name="text-165"/>
+          <p:cNvPr id="5" name="text-158"/>
           <p:cNvSpPr txBox="1"/>
           <p:nvPr/>
         </p:nvSpPr>
@@ -3610,7 +3610,7 @@
       </p:sp>
       <p:sp>
         <p:nvSpPr>
-          <p:cNvPr id="6" name="pill-166"/>
+          <p:cNvPr id="6" name="pill-159"/>
           <p:cNvSpPr/>
           <p:nvPr/>
         </p:nvSpPr>
@@ -3634,7 +3634,7 @@
       </p:sp>
       <p:sp>
         <p:nvSpPr>
-          <p:cNvPr id="7" name="text-167"/>
+          <p:cNvPr id="7" name="text-160"/>
           <p:cNvSpPr txBox="1"/>
           <p:nvPr/>
         </p:nvSpPr>
@@ -3670,7 +3670,7 @@
       </p:sp>
       <p:sp>
         <p:nvSpPr>
-          <p:cNvPr id="8" name="text-168"/>
+          <p:cNvPr id="8" name="text-161"/>
           <p:cNvSpPr txBox="1"/>
           <p:nvPr/>
         </p:nvSpPr>
@@ -4810,7 +4810,7 @@
                   <a:schemeClr val="accent1"/>
                 </a:solidFill>
               </a:rPr>
-              <a:t>ОПЫТ В SMM · 2022–2023</a:t>
+              <a:t>ОПЫТ В SMM И DIGITAL · 2022–2024</a:t>
             </a:r>
             <a:endParaRPr lang="en-US" sz="1400" dirty="0"/>
           </a:p>
@@ -4851,7 +4851,7 @@
                 <a:ea typeface="Arial" pitchFamily="34" charset="-122"/>
                 <a:cs typeface="Arial" pitchFamily="34" charset="-120"/>
               </a:rPr>
-              <a:t>SMM полного цикла в трёх брендах</a:t>
+              <a:t>SMM и digital в трёх брендах</a:t>
             </a:r>
             <a:endParaRPr lang="en-US" sz="3200" dirty="0"/>
           </a:p>
@@ -5271,7 +5271,7 @@
                 <a:ea typeface="Arial" pitchFamily="34" charset="-122"/>
                 <a:cs typeface="Arial" pitchFamily="34" charset="-120"/>
               </a:rPr>
-              <a:t>Innovat</a:t>
+              <a:t>DemirBank</a:t>
             </a:r>
             <a:endParaRPr lang="en-US" sz="1900" dirty="0"/>
           </a:p>
@@ -5307,7 +5307,7 @@
                   <a:schemeClr val="accent5"/>
                 </a:solidFill>
               </a:rPr>
-              <a:t>IT · Digital-маркетолог</a:t>
+              <a:t>Финтех · Digital-маркетолог</a:t>
             </a:r>
             <a:endParaRPr lang="en-US" sz="1200" dirty="0"/>
           </a:p>
@@ -5346,7 +5346,7 @@
                 <a:ea typeface="Arial" pitchFamily="34" charset="-122"/>
                 <a:cs typeface="Arial" pitchFamily="34" charset="-120"/>
               </a:rPr>
-              <a:t>+120%</a:t>
+              <a:t>+40%</a:t>
             </a:r>
             <a:endParaRPr lang="en-US" sz="2600" dirty="0"/>
           </a:p>
@@ -5382,7 +5382,7 @@
                   <a:schemeClr val="tx2"/>
                 </a:solidFill>
               </a:rPr>
-              <a:t>органического трафика. Руководила digital-командой: контент и соцсети.</a:t>
+              <a:t>установок приложения. Таргет и контент для B2B и B2C, аналитика в Firebase.</a:t>
             </a:r>
             <a:endParaRPr lang="en-US" sz="1400" dirty="0"/>
           </a:p>
@@ -6858,7 +6858,7 @@
                   <a:schemeClr val="accent1"/>
                 </a:solidFill>
               </a:rPr>
-              <a:t>ОПЫТ · 2024</a:t>
+              <a:t>ОПЫТ · 2024–2025</a:t>
             </a:r>
             <a:endParaRPr lang="en-US" sz="1400" dirty="0"/>
           </a:p>
@@ -6899,7 +6899,7 @@
                 <a:ea typeface="Arial" pitchFamily="34" charset="-122"/>
                 <a:cs typeface="Arial" pitchFamily="34" charset="-120"/>
               </a:rPr>
-              <a:t>Финтех и международный B2C</a:t>
+              <a:t>Международный B2C: Booking Lane</a:t>
             </a:r>
             <a:endParaRPr lang="en-US" sz="3200" dirty="0"/>
           </a:p>
@@ -6914,11 +6914,11 @@
         <p:spPr>
           <a:xfrm>
             <a:off x="812800" y="2286000"/>
-            <a:ext cx="5181600" cy="3175000"/>
+            <a:ext cx="6248400" cy="2540000"/>
           </a:xfrm>
           <a:prstGeom prst="roundRect">
             <a:avLst>
-              <a:gd name="adj" fmla="val 4800"/>
+              <a:gd name="adj" fmla="val 6000"/>
             </a:avLst>
           </a:prstGeom>
           <a:solidFill>
@@ -6935,47 +6935,141 @@
         </p:nvSpPr>
         <p:spPr>
           <a:xfrm>
-            <a:off x="1117600" y="2540000"/>
-            <a:ext cx="4572000" cy="381000"/>
-          </a:xfrm>
-          <a:prstGeom prst="rect">
-            <a:avLst/>
-          </a:prstGeom>
-          <a:noFill/>
-          <a:ln/>
-        </p:spPr>
-        <p:txBody>
-          <a:bodyPr wrap="square" lIns="0" tIns="0" rIns="0" bIns="0" rtlCol="0" anchor="t"/>
-          <a:lstStyle/>
-          <a:p>
-            <a:pPr indent="0" marL="0">
-              <a:buNone/>
-            </a:pPr>
-            <a:r>
-              <a:rPr lang="en-US" sz="2200" b="1" dirty="0">
-                <a:solidFill>
-                  <a:schemeClr val="tx1"/>
+            <a:off x="1117600" y="2590800"/>
+            <a:ext cx="5638800" cy="571500"/>
+          </a:xfrm>
+          <a:prstGeom prst="rect">
+            <a:avLst/>
+          </a:prstGeom>
+          <a:noFill/>
+          <a:ln/>
+        </p:spPr>
+        <p:txBody>
+          <a:bodyPr wrap="square" lIns="0" tIns="0" rIns="0" bIns="0" rtlCol="0" anchor="t"/>
+          <a:lstStyle/>
+          <a:p>
+            <a:pPr indent="0" marL="0">
+              <a:buNone/>
+            </a:pPr>
+            <a:r>
+              <a:rPr lang="en-US" sz="1400" dirty="0">
+                <a:solidFill>
+                  <a:schemeClr val="accent5"/>
+                </a:solidFill>
+              </a:rPr>
+              <a:t>Маркетолог, частичная занятость · премиальный букинг, США</a:t>
+            </a:r>
+            <a:endParaRPr lang="en-US" sz="1400" dirty="0"/>
+          </a:p>
+        </p:txBody>
+      </p:sp>
+      <p:sp>
+        <p:nvSpPr>
+          <p:cNvPr id="6" name="text-80"/>
+          <p:cNvSpPr txBox="1"/>
+          <p:nvPr/>
+        </p:nvSpPr>
+        <p:spPr>
+          <a:xfrm>
+            <a:off x="1117600" y="3302000"/>
+            <a:ext cx="5638800" cy="1397000"/>
+          </a:xfrm>
+          <a:prstGeom prst="rect">
+            <a:avLst/>
+          </a:prstGeom>
+          <a:noFill/>
+          <a:ln/>
+        </p:spPr>
+        <p:txBody>
+          <a:bodyPr wrap="square" lIns="0" tIns="0" rIns="0" bIns="0" rtlCol="0" anchor="t"/>
+          <a:lstStyle/>
+          <a:p>
+            <a:pPr indent="0" marL="0">
+              <a:buNone/>
+            </a:pPr>
+            <a:r>
+              <a:rPr lang="en-US" sz="1600" dirty="0">
+                <a:solidFill>
+                  <a:schemeClr val="tx2"/>
+                </a:solidFill>
+              </a:rPr>
+              <a:t>Англоязычный рынок: исследование аудитории, медиапланы, контекст и таргет, SEO, отчётность по Google Analytics.</a:t>
+            </a:r>
+            <a:endParaRPr lang="en-US" sz="1600" dirty="0"/>
+          </a:p>
+        </p:txBody>
+      </p:sp>
+      <p:sp>
+        <p:nvSpPr>
+          <p:cNvPr id="7" name="card-81"/>
+          <p:cNvSpPr/>
+          <p:nvPr/>
+        </p:nvSpPr>
+        <p:spPr>
+          <a:xfrm>
+            <a:off x="7264400" y="2286000"/>
+            <a:ext cx="2032000" cy="2540000"/>
+          </a:xfrm>
+          <a:prstGeom prst="roundRect">
+            <a:avLst>
+              <a:gd name="adj" fmla="val 7500"/>
+            </a:avLst>
+          </a:prstGeom>
+          <a:solidFill>
+            <a:schemeClr val="tx1"/>
+          </a:solidFill>
+          <a:ln/>
+        </p:spPr>
+      </p:sp>
+      <p:sp>
+        <p:nvSpPr>
+          <p:cNvPr id="8" name="text-82"/>
+          <p:cNvSpPr txBox="1"/>
+          <p:nvPr/>
+        </p:nvSpPr>
+        <p:spPr>
+          <a:xfrm>
+            <a:off x="7518400" y="2857500"/>
+            <a:ext cx="1524000" cy="635000"/>
+          </a:xfrm>
+          <a:prstGeom prst="rect">
+            <a:avLst/>
+          </a:prstGeom>
+          <a:noFill/>
+          <a:ln/>
+        </p:spPr>
+        <p:txBody>
+          <a:bodyPr wrap="square" lIns="0" tIns="0" rIns="0" bIns="0" rtlCol="0" anchor="t"/>
+          <a:lstStyle/>
+          <a:p>
+            <a:pPr indent="0" marL="0">
+              <a:buNone/>
+            </a:pPr>
+            <a:r>
+              <a:rPr lang="en-US" sz="3200" b="1" dirty="0">
+                <a:solidFill>
+                  <a:schemeClr val="accent2"/>
                 </a:solidFill>
                 <a:latin typeface="Arial" pitchFamily="34" charset="0"/>
                 <a:ea typeface="Arial" pitchFamily="34" charset="-122"/>
                 <a:cs typeface="Arial" pitchFamily="34" charset="-120"/>
               </a:rPr>
-              <a:t>DemirBank</a:t>
-            </a:r>
-            <a:endParaRPr lang="en-US" sz="2200" dirty="0"/>
-          </a:p>
-        </p:txBody>
-      </p:sp>
-      <p:sp>
-        <p:nvSpPr>
-          <p:cNvPr id="6" name="text-80"/>
-          <p:cNvSpPr txBox="1"/>
-          <p:nvPr/>
-        </p:nvSpPr>
-        <p:spPr>
-          <a:xfrm>
-            <a:off x="1117600" y="2984500"/>
-            <a:ext cx="4572000" cy="508000"/>
+              <a:t>4,2</a:t>
+            </a:r>
+            <a:endParaRPr lang="en-US" sz="3200" dirty="0"/>
+          </a:p>
+        </p:txBody>
+      </p:sp>
+      <p:sp>
+        <p:nvSpPr>
+          <p:cNvPr id="9" name="text-83"/>
+          <p:cNvSpPr txBox="1"/>
+          <p:nvPr/>
+        </p:nvSpPr>
+        <p:spPr>
+          <a:xfrm>
+            <a:off x="7518400" y="3619500"/>
+            <a:ext cx="1524000" cy="635000"/>
           </a:xfrm>
           <a:prstGeom prst="rect">
             <a:avLst/>
@@ -6993,10 +7087,10 @@
             <a:r>
               <a:rPr lang="en-US" sz="1400" dirty="0">
                 <a:solidFill>
-                  <a:schemeClr val="accent5"/>
-                </a:solidFill>
-              </a:rPr>
-              <a:t>Digital-маркетолог · первый международный банк Кыргызстана</a:t>
+                  <a:schemeClr val="accent6"/>
+                </a:solidFill>
+              </a:rPr>
+              <a:t>ROAS кампаний</a:t>
             </a:r>
             <a:endParaRPr lang="en-US" sz="1400" dirty="0"/>
           </a:p>
@@ -7004,164 +7098,75 @@
       </p:sp>
       <p:sp>
         <p:nvSpPr>
-          <p:cNvPr id="7" name="text-81"/>
-          <p:cNvSpPr txBox="1"/>
-          <p:nvPr/>
-        </p:nvSpPr>
-        <p:spPr>
-          <a:xfrm>
-            <a:off x="1117600" y="3619500"/>
-            <a:ext cx="2032000" cy="482600"/>
-          </a:xfrm>
-          <a:prstGeom prst="rect">
-            <a:avLst/>
-          </a:prstGeom>
-          <a:noFill/>
-          <a:ln/>
-        </p:spPr>
-        <p:txBody>
-          <a:bodyPr wrap="square" lIns="0" tIns="0" rIns="0" bIns="0" rtlCol="0" anchor="t"/>
-          <a:lstStyle/>
-          <a:p>
-            <a:pPr indent="0" marL="0">
-              <a:buNone/>
-            </a:pPr>
-            <a:r>
-              <a:rPr lang="en-US" sz="2800" b="1" dirty="0">
-                <a:solidFill>
-                  <a:schemeClr val="accent1"/>
+          <p:cNvPr id="10" name="card-84"/>
+          <p:cNvSpPr/>
+          <p:nvPr/>
+        </p:nvSpPr>
+        <p:spPr>
+          <a:xfrm>
+            <a:off x="9398000" y="2286000"/>
+            <a:ext cx="2032000" cy="2540000"/>
+          </a:xfrm>
+          <a:prstGeom prst="roundRect">
+            <a:avLst>
+              <a:gd name="adj" fmla="val 7500"/>
+            </a:avLst>
+          </a:prstGeom>
+          <a:solidFill>
+            <a:schemeClr val="tx1"/>
+          </a:solidFill>
+          <a:ln/>
+        </p:spPr>
+      </p:sp>
+      <p:sp>
+        <p:nvSpPr>
+          <p:cNvPr id="11" name="text-85"/>
+          <p:cNvSpPr txBox="1"/>
+          <p:nvPr/>
+        </p:nvSpPr>
+        <p:spPr>
+          <a:xfrm>
+            <a:off x="9652000" y="2857500"/>
+            <a:ext cx="1524000" cy="635000"/>
+          </a:xfrm>
+          <a:prstGeom prst="rect">
+            <a:avLst/>
+          </a:prstGeom>
+          <a:noFill/>
+          <a:ln/>
+        </p:spPr>
+        <p:txBody>
+          <a:bodyPr wrap="square" lIns="0" tIns="0" rIns="0" bIns="0" rtlCol="0" anchor="t"/>
+          <a:lstStyle/>
+          <a:p>
+            <a:pPr indent="0" marL="0">
+              <a:buNone/>
+            </a:pPr>
+            <a:r>
+              <a:rPr lang="en-US" sz="3200" b="1" dirty="0">
+                <a:solidFill>
+                  <a:schemeClr val="accent2"/>
                 </a:solidFill>
                 <a:latin typeface="Arial" pitchFamily="34" charset="0"/>
                 <a:ea typeface="Arial" pitchFamily="34" charset="-122"/>
                 <a:cs typeface="Arial" pitchFamily="34" charset="-120"/>
               </a:rPr>
-              <a:t>+40%</a:t>
-            </a:r>
-            <a:endParaRPr lang="en-US" sz="2800" dirty="0"/>
-          </a:p>
-        </p:txBody>
-      </p:sp>
-      <p:sp>
-        <p:nvSpPr>
-          <p:cNvPr id="8" name="text-82"/>
-          <p:cNvSpPr txBox="1"/>
-          <p:nvPr/>
-        </p:nvSpPr>
-        <p:spPr>
-          <a:xfrm>
-            <a:off x="1117600" y="4140200"/>
-            <a:ext cx="2032000" cy="254000"/>
-          </a:xfrm>
-          <a:prstGeom prst="rect">
-            <a:avLst/>
-          </a:prstGeom>
-          <a:noFill/>
-          <a:ln/>
-        </p:spPr>
-        <p:txBody>
-          <a:bodyPr wrap="square" lIns="0" tIns="0" rIns="0" bIns="0" rtlCol="0" anchor="t"/>
-          <a:lstStyle/>
-          <a:p>
-            <a:pPr indent="0" marL="0">
-              <a:buNone/>
-            </a:pPr>
-            <a:r>
-              <a:rPr lang="en-US" sz="1200" dirty="0">
-                <a:solidFill>
-                  <a:schemeClr val="tx2"/>
-                </a:solidFill>
-              </a:rPr>
-              <a:t>установок приложения</a:t>
-            </a:r>
-            <a:endParaRPr lang="en-US" sz="1200" dirty="0"/>
-          </a:p>
-        </p:txBody>
-      </p:sp>
-      <p:sp>
-        <p:nvSpPr>
-          <p:cNvPr id="9" name="text-83"/>
-          <p:cNvSpPr txBox="1"/>
-          <p:nvPr/>
-        </p:nvSpPr>
-        <p:spPr>
-          <a:xfrm>
-            <a:off x="3276600" y="3619500"/>
-            <a:ext cx="2032000" cy="482600"/>
-          </a:xfrm>
-          <a:prstGeom prst="rect">
-            <a:avLst/>
-          </a:prstGeom>
-          <a:noFill/>
-          <a:ln/>
-        </p:spPr>
-        <p:txBody>
-          <a:bodyPr wrap="square" lIns="0" tIns="0" rIns="0" bIns="0" rtlCol="0" anchor="t"/>
-          <a:lstStyle/>
-          <a:p>
-            <a:pPr indent="0" marL="0">
-              <a:buNone/>
-            </a:pPr>
-            <a:r>
-              <a:rPr lang="en-US" sz="2800" b="1" dirty="0">
-                <a:solidFill>
-                  <a:schemeClr val="accent1"/>
-                </a:solidFill>
-                <a:latin typeface="Arial" pitchFamily="34" charset="0"/>
-                <a:ea typeface="Arial" pitchFamily="34" charset="-122"/>
-                <a:cs typeface="Arial" pitchFamily="34" charset="-120"/>
-              </a:rPr>
-              <a:t>−25%</a:t>
-            </a:r>
-            <a:endParaRPr lang="en-US" sz="2800" dirty="0"/>
-          </a:p>
-        </p:txBody>
-      </p:sp>
-      <p:sp>
-        <p:nvSpPr>
-          <p:cNvPr id="10" name="text-84"/>
-          <p:cNvSpPr txBox="1"/>
-          <p:nvPr/>
-        </p:nvSpPr>
-        <p:spPr>
-          <a:xfrm>
-            <a:off x="3276600" y="4140200"/>
-            <a:ext cx="2032000" cy="254000"/>
-          </a:xfrm>
-          <a:prstGeom prst="rect">
-            <a:avLst/>
-          </a:prstGeom>
-          <a:noFill/>
-          <a:ln/>
-        </p:spPr>
-        <p:txBody>
-          <a:bodyPr wrap="square" lIns="0" tIns="0" rIns="0" bIns="0" rtlCol="0" anchor="t"/>
-          <a:lstStyle/>
-          <a:p>
-            <a:pPr indent="0" marL="0">
-              <a:buNone/>
-            </a:pPr>
-            <a:r>
-              <a:rPr lang="en-US" sz="1200" dirty="0">
-                <a:solidFill>
-                  <a:schemeClr val="tx2"/>
-                </a:solidFill>
-              </a:rPr>
-              <a:t>стоимость установки</a:t>
-            </a:r>
-            <a:endParaRPr lang="en-US" sz="1200" dirty="0"/>
-          </a:p>
-        </p:txBody>
-      </p:sp>
-      <p:sp>
-        <p:nvSpPr>
-          <p:cNvPr id="11" name="text-85"/>
-          <p:cNvSpPr txBox="1"/>
-          <p:nvPr/>
-        </p:nvSpPr>
-        <p:spPr>
-          <a:xfrm>
-            <a:off x="1117600" y="4635500"/>
-            <a:ext cx="4572000" cy="635000"/>
+              <a:t>+90%</a:t>
+            </a:r>
+            <a:endParaRPr lang="en-US" sz="3200" dirty="0"/>
+          </a:p>
+        </p:txBody>
+      </p:sp>
+      <p:sp>
+        <p:nvSpPr>
+          <p:cNvPr id="12" name="text-86"/>
+          <p:cNvSpPr txBox="1"/>
+          <p:nvPr/>
+        </p:nvSpPr>
+        <p:spPr>
+          <a:xfrm>
+            <a:off x="9652000" y="3619500"/>
+            <a:ext cx="1524000" cy="635000"/>
           </a:xfrm>
           <a:prstGeom prst="rect">
             <a:avLst/>
@@ -7179,293 +7184,10 @@
             <a:r>
               <a:rPr lang="en-US" sz="1400" dirty="0">
                 <a:solidFill>
-                  <a:schemeClr val="tx2"/>
-                </a:solidFill>
-              </a:rPr>
-              <a:t>Медиапланы, контекст и таргет, аналитика в GA и Firebase, SEO сайта.</a:t>
-            </a:r>
-            <a:endParaRPr lang="en-US" sz="1400" dirty="0"/>
-          </a:p>
-        </p:txBody>
-      </p:sp>
-      <p:sp>
-        <p:nvSpPr>
-          <p:cNvPr id="12" name="card-86"/>
-          <p:cNvSpPr/>
-          <p:nvPr/>
-        </p:nvSpPr>
-        <p:spPr>
-          <a:xfrm>
-            <a:off x="6197600" y="2286000"/>
-            <a:ext cx="5181600" cy="3175000"/>
-          </a:xfrm>
-          <a:prstGeom prst="roundRect">
-            <a:avLst>
-              <a:gd name="adj" fmla="val 4800"/>
-            </a:avLst>
-          </a:prstGeom>
-          <a:solidFill>
-            <a:schemeClr val="accent3"/>
-          </a:solidFill>
-          <a:ln/>
-        </p:spPr>
-      </p:sp>
-      <p:sp>
-        <p:nvSpPr>
-          <p:cNvPr id="13" name="text-87"/>
-          <p:cNvSpPr txBox="1"/>
-          <p:nvPr/>
-        </p:nvSpPr>
-        <p:spPr>
-          <a:xfrm>
-            <a:off x="6502400" y="2540000"/>
-            <a:ext cx="4572000" cy="381000"/>
-          </a:xfrm>
-          <a:prstGeom prst="rect">
-            <a:avLst/>
-          </a:prstGeom>
-          <a:noFill/>
-          <a:ln/>
-        </p:spPr>
-        <p:txBody>
-          <a:bodyPr wrap="square" lIns="0" tIns="0" rIns="0" bIns="0" rtlCol="0" anchor="t"/>
-          <a:lstStyle/>
-          <a:p>
-            <a:pPr indent="0" marL="0">
-              <a:buNone/>
-            </a:pPr>
-            <a:r>
-              <a:rPr lang="en-US" sz="2200" b="1" dirty="0">
-                <a:solidFill>
-                  <a:schemeClr val="tx1"/>
-                </a:solidFill>
-                <a:latin typeface="Arial" pitchFamily="34" charset="0"/>
-                <a:ea typeface="Arial" pitchFamily="34" charset="-122"/>
-                <a:cs typeface="Arial" pitchFamily="34" charset="-120"/>
-              </a:rPr>
-              <a:t>Booking Lane</a:t>
-            </a:r>
-            <a:endParaRPr lang="en-US" sz="2200" dirty="0"/>
-          </a:p>
-        </p:txBody>
-      </p:sp>
-      <p:sp>
-        <p:nvSpPr>
-          <p:cNvPr id="14" name="text-88"/>
-          <p:cNvSpPr txBox="1"/>
-          <p:nvPr/>
-        </p:nvSpPr>
-        <p:spPr>
-          <a:xfrm>
-            <a:off x="6502400" y="2984500"/>
-            <a:ext cx="4572000" cy="508000"/>
-          </a:xfrm>
-          <a:prstGeom prst="rect">
-            <a:avLst/>
-          </a:prstGeom>
-          <a:noFill/>
-          <a:ln/>
-        </p:spPr>
-        <p:txBody>
-          <a:bodyPr wrap="square" lIns="0" tIns="0" rIns="0" bIns="0" rtlCol="0" anchor="t"/>
-          <a:lstStyle/>
-          <a:p>
-            <a:pPr indent="0" marL="0">
-              <a:buNone/>
-            </a:pPr>
-            <a:r>
-              <a:rPr lang="en-US" sz="1400" dirty="0">
-                <a:solidFill>
-                  <a:schemeClr val="accent5"/>
-                </a:solidFill>
-              </a:rPr>
-              <a:t>Маркетолог, частичная занятость · премиальный букинг, США</a:t>
-            </a:r>
-            <a:endParaRPr lang="en-US" sz="1400" dirty="0"/>
-          </a:p>
-        </p:txBody>
-      </p:sp>
-      <p:sp>
-        <p:nvSpPr>
-          <p:cNvPr id="15" name="text-89"/>
-          <p:cNvSpPr txBox="1"/>
-          <p:nvPr/>
-        </p:nvSpPr>
-        <p:spPr>
-          <a:xfrm>
-            <a:off x="6502400" y="3619500"/>
-            <a:ext cx="2032000" cy="482600"/>
-          </a:xfrm>
-          <a:prstGeom prst="rect">
-            <a:avLst/>
-          </a:prstGeom>
-          <a:noFill/>
-          <a:ln/>
-        </p:spPr>
-        <p:txBody>
-          <a:bodyPr wrap="square" lIns="0" tIns="0" rIns="0" bIns="0" rtlCol="0" anchor="t"/>
-          <a:lstStyle/>
-          <a:p>
-            <a:pPr indent="0" marL="0">
-              <a:buNone/>
-            </a:pPr>
-            <a:r>
-              <a:rPr lang="en-US" sz="2800" b="1" dirty="0">
-                <a:solidFill>
-                  <a:schemeClr val="accent1"/>
-                </a:solidFill>
-                <a:latin typeface="Arial" pitchFamily="34" charset="0"/>
-                <a:ea typeface="Arial" pitchFamily="34" charset="-122"/>
-                <a:cs typeface="Arial" pitchFamily="34" charset="-120"/>
-              </a:rPr>
-              <a:t>4,2</a:t>
-            </a:r>
-            <a:endParaRPr lang="en-US" sz="2800" dirty="0"/>
-          </a:p>
-        </p:txBody>
-      </p:sp>
-      <p:sp>
-        <p:nvSpPr>
-          <p:cNvPr id="16" name="text-90"/>
-          <p:cNvSpPr txBox="1"/>
-          <p:nvPr/>
-        </p:nvSpPr>
-        <p:spPr>
-          <a:xfrm>
-            <a:off x="6502400" y="4140200"/>
-            <a:ext cx="2032000" cy="254000"/>
-          </a:xfrm>
-          <a:prstGeom prst="rect">
-            <a:avLst/>
-          </a:prstGeom>
-          <a:noFill/>
-          <a:ln/>
-        </p:spPr>
-        <p:txBody>
-          <a:bodyPr wrap="square" lIns="0" tIns="0" rIns="0" bIns="0" rtlCol="0" anchor="t"/>
-          <a:lstStyle/>
-          <a:p>
-            <a:pPr indent="0" marL="0">
-              <a:buNone/>
-            </a:pPr>
-            <a:r>
-              <a:rPr lang="en-US" sz="1200" dirty="0">
-                <a:solidFill>
-                  <a:schemeClr val="tx2"/>
-                </a:solidFill>
-              </a:rPr>
-              <a:t>ROAS кампаний</a:t>
-            </a:r>
-            <a:endParaRPr lang="en-US" sz="1200" dirty="0"/>
-          </a:p>
-        </p:txBody>
-      </p:sp>
-      <p:sp>
-        <p:nvSpPr>
-          <p:cNvPr id="17" name="text-91"/>
-          <p:cNvSpPr txBox="1"/>
-          <p:nvPr/>
-        </p:nvSpPr>
-        <p:spPr>
-          <a:xfrm>
-            <a:off x="8661400" y="3619500"/>
-            <a:ext cx="2032000" cy="482600"/>
-          </a:xfrm>
-          <a:prstGeom prst="rect">
-            <a:avLst/>
-          </a:prstGeom>
-          <a:noFill/>
-          <a:ln/>
-        </p:spPr>
-        <p:txBody>
-          <a:bodyPr wrap="square" lIns="0" tIns="0" rIns="0" bIns="0" rtlCol="0" anchor="t"/>
-          <a:lstStyle/>
-          <a:p>
-            <a:pPr indent="0" marL="0">
-              <a:buNone/>
-            </a:pPr>
-            <a:r>
-              <a:rPr lang="en-US" sz="2800" b="1" dirty="0">
-                <a:solidFill>
-                  <a:schemeClr val="accent1"/>
-                </a:solidFill>
-                <a:latin typeface="Arial" pitchFamily="34" charset="0"/>
-                <a:ea typeface="Arial" pitchFamily="34" charset="-122"/>
-                <a:cs typeface="Arial" pitchFamily="34" charset="-120"/>
-              </a:rPr>
-              <a:t>+90%</a:t>
-            </a:r>
-            <a:endParaRPr lang="en-US" sz="2800" dirty="0"/>
-          </a:p>
-        </p:txBody>
-      </p:sp>
-      <p:sp>
-        <p:nvSpPr>
-          <p:cNvPr id="18" name="text-92"/>
-          <p:cNvSpPr txBox="1"/>
-          <p:nvPr/>
-        </p:nvSpPr>
-        <p:spPr>
-          <a:xfrm>
-            <a:off x="8661400" y="4140200"/>
-            <a:ext cx="2032000" cy="254000"/>
-          </a:xfrm>
-          <a:prstGeom prst="rect">
-            <a:avLst/>
-          </a:prstGeom>
-          <a:noFill/>
-          <a:ln/>
-        </p:spPr>
-        <p:txBody>
-          <a:bodyPr wrap="square" lIns="0" tIns="0" rIns="0" bIns="0" rtlCol="0" anchor="t"/>
-          <a:lstStyle/>
-          <a:p>
-            <a:pPr indent="0" marL="0">
-              <a:buNone/>
-            </a:pPr>
-            <a:r>
-              <a:rPr lang="en-US" sz="1200" dirty="0">
-                <a:solidFill>
-                  <a:schemeClr val="tx2"/>
+                  <a:schemeClr val="accent6"/>
                 </a:solidFill>
               </a:rPr>
               <a:t>органики за 5 месяцев</a:t>
-            </a:r>
-            <a:endParaRPr lang="en-US" sz="1200" dirty="0"/>
-          </a:p>
-        </p:txBody>
-      </p:sp>
-      <p:sp>
-        <p:nvSpPr>
-          <p:cNvPr id="19" name="text-93"/>
-          <p:cNvSpPr txBox="1"/>
-          <p:nvPr/>
-        </p:nvSpPr>
-        <p:spPr>
-          <a:xfrm>
-            <a:off x="6502400" y="4635500"/>
-            <a:ext cx="4572000" cy="635000"/>
-          </a:xfrm>
-          <a:prstGeom prst="rect">
-            <a:avLst/>
-          </a:prstGeom>
-          <a:noFill/>
-          <a:ln/>
-        </p:spPr>
-        <p:txBody>
-          <a:bodyPr wrap="square" lIns="0" tIns="0" rIns="0" bIns="0" rtlCol="0" anchor="t"/>
-          <a:lstStyle/>
-          <a:p>
-            <a:pPr indent="0" marL="0">
-              <a:buNone/>
-            </a:pPr>
-            <a:r>
-              <a:rPr lang="en-US" sz="1400" dirty="0">
-                <a:solidFill>
-                  <a:schemeClr val="tx2"/>
-                </a:solidFill>
-              </a:rPr>
-              <a:t>Англоязычный рынок, исследование аудитории, SEO и отчётность по GA.</a:t>
             </a:r>
             <a:endParaRPr lang="en-US" sz="1400" dirty="0"/>
           </a:p>
@@ -7622,7 +7344,7 @@
       </p:sp>
       <p:sp>
         <p:nvSpPr>
-          <p:cNvPr id="4" name="rule-94"/>
+          <p:cNvPr id="4" name="rule-87"/>
           <p:cNvSpPr/>
           <p:nvPr/>
         </p:nvSpPr>
@@ -7645,7 +7367,7 @@
       </p:sp>
       <p:sp>
         <p:nvSpPr>
-          <p:cNvPr id="5" name="text-95"/>
+          <p:cNvPr id="5" name="text-88"/>
           <p:cNvSpPr txBox="1"/>
           <p:nvPr/>
         </p:nvSpPr>
@@ -7681,7 +7403,7 @@
       </p:sp>
       <p:sp>
         <p:nvSpPr>
-          <p:cNvPr id="6" name="text-96"/>
+          <p:cNvPr id="6" name="text-89"/>
           <p:cNvSpPr txBox="1"/>
           <p:nvPr/>
         </p:nvSpPr>
@@ -7717,7 +7439,7 @@
       </p:sp>
       <p:sp>
         <p:nvSpPr>
-          <p:cNvPr id="7" name="rule-97"/>
+          <p:cNvPr id="7" name="rule-90"/>
           <p:cNvSpPr/>
           <p:nvPr/>
         </p:nvSpPr>
@@ -7740,7 +7462,7 @@
       </p:sp>
       <p:sp>
         <p:nvSpPr>
-          <p:cNvPr id="8" name="text-98"/>
+          <p:cNvPr id="8" name="text-91"/>
           <p:cNvSpPr txBox="1"/>
           <p:nvPr/>
         </p:nvSpPr>
@@ -7776,7 +7498,7 @@
       </p:sp>
       <p:sp>
         <p:nvSpPr>
-          <p:cNvPr id="9" name="text-99"/>
+          <p:cNvPr id="9" name="text-92"/>
           <p:cNvSpPr txBox="1"/>
           <p:nvPr/>
         </p:nvSpPr>
@@ -7812,7 +7534,7 @@
       </p:sp>
       <p:sp>
         <p:nvSpPr>
-          <p:cNvPr id="10" name="rule-100"/>
+          <p:cNvPr id="10" name="rule-93"/>
           <p:cNvSpPr/>
           <p:nvPr/>
         </p:nvSpPr>
@@ -7835,7 +7557,7 @@
       </p:sp>
       <p:sp>
         <p:nvSpPr>
-          <p:cNvPr id="11" name="text-101"/>
+          <p:cNvPr id="11" name="text-94"/>
           <p:cNvSpPr txBox="1"/>
           <p:nvPr/>
         </p:nvSpPr>
@@ -7871,7 +7593,7 @@
       </p:sp>
       <p:sp>
         <p:nvSpPr>
-          <p:cNvPr id="12" name="text-102"/>
+          <p:cNvPr id="12" name="text-95"/>
           <p:cNvSpPr txBox="1"/>
           <p:nvPr/>
         </p:nvSpPr>
@@ -7907,7 +7629,7 @@
       </p:sp>
       <p:sp>
         <p:nvSpPr>
-          <p:cNvPr id="13" name="rule-103"/>
+          <p:cNvPr id="13" name="rule-96"/>
           <p:cNvSpPr/>
           <p:nvPr/>
         </p:nvSpPr>
@@ -7930,7 +7652,7 @@
       </p:sp>
       <p:sp>
         <p:nvSpPr>
-          <p:cNvPr id="14" name="text-104"/>
+          <p:cNvPr id="14" name="text-97"/>
           <p:cNvSpPr txBox="1"/>
           <p:nvPr/>
         </p:nvSpPr>
@@ -7966,7 +7688,7 @@
       </p:sp>
       <p:sp>
         <p:nvSpPr>
-          <p:cNvPr id="15" name="text-105"/>
+          <p:cNvPr id="15" name="text-98"/>
           <p:cNvSpPr txBox="1"/>
           <p:nvPr/>
         </p:nvSpPr>
@@ -8002,7 +7724,7 @@
       </p:sp>
       <p:sp>
         <p:nvSpPr>
-          <p:cNvPr id="16" name="rule-106"/>
+          <p:cNvPr id="16" name="rule-99"/>
           <p:cNvSpPr/>
           <p:nvPr/>
         </p:nvSpPr>
@@ -8025,7 +7747,7 @@
       </p:sp>
       <p:sp>
         <p:nvSpPr>
-          <p:cNvPr id="17" name="text-107"/>
+          <p:cNvPr id="17" name="text-100"/>
           <p:cNvSpPr txBox="1"/>
           <p:nvPr/>
         </p:nvSpPr>
@@ -8061,7 +7783,7 @@
       </p:sp>
       <p:sp>
         <p:nvSpPr>
-          <p:cNvPr id="18" name="text-108"/>
+          <p:cNvPr id="18" name="text-101"/>
           <p:cNvSpPr txBox="1"/>
           <p:nvPr/>
         </p:nvSpPr>
@@ -8097,7 +7819,7 @@
       </p:sp>
       <p:sp>
         <p:nvSpPr>
-          <p:cNvPr id="19" name="rule-109"/>
+          <p:cNvPr id="19" name="rule-102"/>
           <p:cNvSpPr/>
           <p:nvPr/>
         </p:nvSpPr>
@@ -8120,7 +7842,7 @@
       </p:sp>
       <p:sp>
         <p:nvSpPr>
-          <p:cNvPr id="20" name="text-110"/>
+          <p:cNvPr id="20" name="text-103"/>
           <p:cNvSpPr txBox="1"/>
           <p:nvPr/>
         </p:nvSpPr>
@@ -8156,7 +7878,7 @@
       </p:sp>
       <p:sp>
         <p:nvSpPr>
-          <p:cNvPr id="21" name="text-111"/>
+          <p:cNvPr id="21" name="text-104"/>
           <p:cNvSpPr txBox="1"/>
           <p:nvPr/>
         </p:nvSpPr>
@@ -8341,7 +8063,7 @@
       </p:sp>
       <p:sp>
         <p:nvSpPr>
-          <p:cNvPr id="5" name="text-112"/>
+          <p:cNvPr id="5" name="text-105"/>
           <p:cNvSpPr txBox="1"/>
           <p:nvPr/>
         </p:nvSpPr>
@@ -8377,7 +8099,7 @@
       </p:sp>
       <p:sp>
         <p:nvSpPr>
-          <p:cNvPr id="6" name="pill-113"/>
+          <p:cNvPr id="6" name="pill-106"/>
           <p:cNvSpPr/>
           <p:nvPr/>
         </p:nvSpPr>
@@ -8399,7 +8121,7 @@
       </p:sp>
       <p:sp>
         <p:nvSpPr>
-          <p:cNvPr id="7" name="text-114"/>
+          <p:cNvPr id="7" name="text-107"/>
           <p:cNvSpPr txBox="1"/>
           <p:nvPr/>
         </p:nvSpPr>
@@ -8435,7 +8157,7 @@
       </p:sp>
       <p:sp>
         <p:nvSpPr>
-          <p:cNvPr id="8" name="pill-115"/>
+          <p:cNvPr id="8" name="pill-108"/>
           <p:cNvSpPr/>
           <p:nvPr/>
         </p:nvSpPr>
@@ -8457,7 +8179,7 @@
       </p:sp>
       <p:sp>
         <p:nvSpPr>
-          <p:cNvPr id="9" name="text-116"/>
+          <p:cNvPr id="9" name="text-109"/>
           <p:cNvSpPr txBox="1"/>
           <p:nvPr/>
         </p:nvSpPr>
@@ -8493,7 +8215,7 @@
       </p:sp>
       <p:sp>
         <p:nvSpPr>
-          <p:cNvPr id="10" name="pill-117"/>
+          <p:cNvPr id="10" name="pill-110"/>
           <p:cNvSpPr/>
           <p:nvPr/>
         </p:nvSpPr>
@@ -8515,7 +8237,7 @@
       </p:sp>
       <p:sp>
         <p:nvSpPr>
-          <p:cNvPr id="11" name="text-118"/>
+          <p:cNvPr id="11" name="text-111"/>
           <p:cNvSpPr txBox="1"/>
           <p:nvPr/>
         </p:nvSpPr>
@@ -8551,7 +8273,7 @@
       </p:sp>
       <p:sp>
         <p:nvSpPr>
-          <p:cNvPr id="12" name="pill-119"/>
+          <p:cNvPr id="12" name="pill-112"/>
           <p:cNvSpPr/>
           <p:nvPr/>
         </p:nvSpPr>
@@ -8573,7 +8295,7 @@
       </p:sp>
       <p:sp>
         <p:nvSpPr>
-          <p:cNvPr id="13" name="text-120"/>
+          <p:cNvPr id="13" name="text-113"/>
           <p:cNvSpPr txBox="1"/>
           <p:nvPr/>
         </p:nvSpPr>
@@ -8609,7 +8331,7 @@
       </p:sp>
       <p:sp>
         <p:nvSpPr>
-          <p:cNvPr id="14" name="pill-121"/>
+          <p:cNvPr id="14" name="pill-114"/>
           <p:cNvSpPr/>
           <p:nvPr/>
         </p:nvSpPr>
@@ -8631,7 +8353,7 @@
       </p:sp>
       <p:sp>
         <p:nvSpPr>
-          <p:cNvPr id="15" name="text-122"/>
+          <p:cNvPr id="15" name="text-115"/>
           <p:cNvSpPr txBox="1"/>
           <p:nvPr/>
         </p:nvSpPr>
@@ -8667,7 +8389,7 @@
       </p:sp>
       <p:sp>
         <p:nvSpPr>
-          <p:cNvPr id="16" name="pill-123"/>
+          <p:cNvPr id="16" name="pill-116"/>
           <p:cNvSpPr/>
           <p:nvPr/>
         </p:nvSpPr>
@@ -8689,7 +8411,7 @@
       </p:sp>
       <p:sp>
         <p:nvSpPr>
-          <p:cNvPr id="17" name="text-124"/>
+          <p:cNvPr id="17" name="text-117"/>
           <p:cNvSpPr txBox="1"/>
           <p:nvPr/>
         </p:nvSpPr>
@@ -8725,7 +8447,7 @@
       </p:sp>
       <p:sp>
         <p:nvSpPr>
-          <p:cNvPr id="18" name="text-125"/>
+          <p:cNvPr id="18" name="text-118"/>
           <p:cNvSpPr txBox="1"/>
           <p:nvPr/>
         </p:nvSpPr>
@@ -8761,7 +8483,7 @@
       </p:sp>
       <p:sp>
         <p:nvSpPr>
-          <p:cNvPr id="19" name="pill-126"/>
+          <p:cNvPr id="19" name="pill-119"/>
           <p:cNvSpPr/>
           <p:nvPr/>
         </p:nvSpPr>
@@ -8783,7 +8505,7 @@
       </p:sp>
       <p:sp>
         <p:nvSpPr>
-          <p:cNvPr id="20" name="text-127"/>
+          <p:cNvPr id="20" name="text-120"/>
           <p:cNvSpPr txBox="1"/>
           <p:nvPr/>
         </p:nvSpPr>
@@ -8819,7 +8541,7 @@
       </p:sp>
       <p:sp>
         <p:nvSpPr>
-          <p:cNvPr id="21" name="pill-128"/>
+          <p:cNvPr id="21" name="pill-121"/>
           <p:cNvSpPr/>
           <p:nvPr/>
         </p:nvSpPr>
@@ -8841,7 +8563,7 @@
       </p:sp>
       <p:sp>
         <p:nvSpPr>
-          <p:cNvPr id="22" name="text-129"/>
+          <p:cNvPr id="22" name="text-122"/>
           <p:cNvSpPr txBox="1"/>
           <p:nvPr/>
         </p:nvSpPr>
@@ -8877,7 +8599,7 @@
       </p:sp>
       <p:sp>
         <p:nvSpPr>
-          <p:cNvPr id="23" name="pill-130"/>
+          <p:cNvPr id="23" name="pill-123"/>
           <p:cNvSpPr/>
           <p:nvPr/>
         </p:nvSpPr>
@@ -8899,7 +8621,7 @@
       </p:sp>
       <p:sp>
         <p:nvSpPr>
-          <p:cNvPr id="24" name="text-131"/>
+          <p:cNvPr id="24" name="text-124"/>
           <p:cNvSpPr txBox="1"/>
           <p:nvPr/>
         </p:nvSpPr>
@@ -8935,7 +8657,7 @@
       </p:sp>
       <p:sp>
         <p:nvSpPr>
-          <p:cNvPr id="25" name="pill-132"/>
+          <p:cNvPr id="25" name="pill-125"/>
           <p:cNvSpPr/>
           <p:nvPr/>
         </p:nvSpPr>
@@ -8957,7 +8679,7 @@
       </p:sp>
       <p:sp>
         <p:nvSpPr>
-          <p:cNvPr id="26" name="text-133"/>
+          <p:cNvPr id="26" name="text-126"/>
           <p:cNvSpPr txBox="1"/>
           <p:nvPr/>
         </p:nvSpPr>
@@ -8993,7 +8715,7 @@
       </p:sp>
       <p:sp>
         <p:nvSpPr>
-          <p:cNvPr id="27" name="text-134"/>
+          <p:cNvPr id="27" name="text-127"/>
           <p:cNvSpPr txBox="1"/>
           <p:nvPr/>
         </p:nvSpPr>
@@ -9029,7 +8751,7 @@
       </p:sp>
       <p:sp>
         <p:nvSpPr>
-          <p:cNvPr id="28" name="pill-135"/>
+          <p:cNvPr id="28" name="pill-128"/>
           <p:cNvSpPr/>
           <p:nvPr/>
         </p:nvSpPr>
@@ -9053,7 +8775,7 @@
       </p:sp>
       <p:sp>
         <p:nvSpPr>
-          <p:cNvPr id="29" name="text-136"/>
+          <p:cNvPr id="29" name="text-129"/>
           <p:cNvSpPr txBox="1"/>
           <p:nvPr/>
         </p:nvSpPr>
@@ -9089,7 +8811,7 @@
       </p:sp>
       <p:sp>
         <p:nvSpPr>
-          <p:cNvPr id="30" name="pill-137"/>
+          <p:cNvPr id="30" name="pill-130"/>
           <p:cNvSpPr/>
           <p:nvPr/>
         </p:nvSpPr>
@@ -9113,7 +8835,7 @@
       </p:sp>
       <p:sp>
         <p:nvSpPr>
-          <p:cNvPr id="31" name="text-138"/>
+          <p:cNvPr id="31" name="text-131"/>
           <p:cNvSpPr txBox="1"/>
           <p:nvPr/>
         </p:nvSpPr>
@@ -9149,7 +8871,7 @@
       </p:sp>
       <p:sp>
         <p:nvSpPr>
-          <p:cNvPr id="32" name="pill-139"/>
+          <p:cNvPr id="32" name="pill-132"/>
           <p:cNvSpPr/>
           <p:nvPr/>
         </p:nvSpPr>
@@ -9173,7 +8895,7 @@
       </p:sp>
       <p:sp>
         <p:nvSpPr>
-          <p:cNvPr id="33" name="text-140"/>
+          <p:cNvPr id="33" name="text-133"/>
           <p:cNvSpPr txBox="1"/>
           <p:nvPr/>
         </p:nvSpPr>
@@ -9209,7 +8931,7 @@
       </p:sp>
       <p:sp>
         <p:nvSpPr>
-          <p:cNvPr id="34" name="pill-141"/>
+          <p:cNvPr id="34" name="pill-134"/>
           <p:cNvSpPr/>
           <p:nvPr/>
         </p:nvSpPr>
@@ -9233,7 +8955,7 @@
       </p:sp>
       <p:sp>
         <p:nvSpPr>
-          <p:cNvPr id="35" name="text-142"/>
+          <p:cNvPr id="35" name="text-135"/>
           <p:cNvSpPr txBox="1"/>
           <p:nvPr/>
         </p:nvSpPr>
@@ -9269,7 +8991,7 @@
       </p:sp>
       <p:sp>
         <p:nvSpPr>
-          <p:cNvPr id="36" name="pill-143"/>
+          <p:cNvPr id="36" name="pill-136"/>
           <p:cNvSpPr/>
           <p:nvPr/>
         </p:nvSpPr>
@@ -9293,7 +9015,7 @@
       </p:sp>
       <p:sp>
         <p:nvSpPr>
-          <p:cNvPr id="37" name="text-144"/>
+          <p:cNvPr id="37" name="text-137"/>
           <p:cNvSpPr txBox="1"/>
           <p:nvPr/>
         </p:nvSpPr>
@@ -9329,7 +9051,7 @@
       </p:sp>
       <p:sp>
         <p:nvSpPr>
-          <p:cNvPr id="38" name="pill-145"/>
+          <p:cNvPr id="38" name="pill-138"/>
           <p:cNvSpPr/>
           <p:nvPr/>
         </p:nvSpPr>
@@ -9353,7 +9075,7 @@
       </p:sp>
       <p:sp>
         <p:nvSpPr>
-          <p:cNvPr id="39" name="text-146"/>
+          <p:cNvPr id="39" name="text-139"/>
           <p:cNvSpPr txBox="1"/>
           <p:nvPr/>
         </p:nvSpPr>
@@ -9389,7 +9111,7 @@
       </p:sp>
       <p:sp>
         <p:nvSpPr>
-          <p:cNvPr id="40" name="pill-147"/>
+          <p:cNvPr id="40" name="pill-140"/>
           <p:cNvSpPr/>
           <p:nvPr/>
         </p:nvSpPr>
@@ -9413,7 +9135,7 @@
       </p:sp>
       <p:sp>
         <p:nvSpPr>
-          <p:cNvPr id="41" name="text-148"/>
+          <p:cNvPr id="41" name="text-141"/>
           <p:cNvSpPr txBox="1"/>
           <p:nvPr/>
         </p:nvSpPr>

</xml_diff>

<commit_message>
Remove placeholder brackets from tool names
Co-Authored-By: Claude Opus 5.5 <noreply@anthropic.com>
Claude-Session: https://claude.ai/code/session_01VE1bLi5VTBXn7QwuZiU1Kc
</commit_message>
<xml_diff>
--- a/presentation/Kangeldieva_SMM.pptx
+++ b/presentation/Kangeldieva_SMM.pptx
@@ -117,13 +117,13 @@
   <p:extLst>
     <p:ext uri="{521415D9-36F7-43E2-AB2F-B90AF26B5E84}">
       <p14:sectionLst xmlns:p14="http://schemas.microsoft.com/office/powerpoint/2010/main">
-        <p14:section name="Кто я" id="{58d39aa0-56f7-bef9-1af6-a555b6d126b5}">
+        <p14:section name="Кто я" id="{d6e69f4e-0694-4190-0685-8a2defcebd84}">
           <p14:sldIdLst>
             <p14:sldId id="256"/>
             <p14:sldId id="257"/>
           </p14:sldIdLst>
         </p14:section>
-        <p14:section name="Результаты и опыт" id="{e7890bd4-9617-996a-825a-42f69a9d7fe7}">
+        <p14:section name="Результаты и опыт" id="{83e34d7d-1109-c891-3667-576689c4dec4}">
           <p14:sldIdLst>
             <p14:sldId id="258"/>
             <p14:sldId id="259"/>
@@ -132,13 +132,13 @@
             <p14:sldId id="262"/>
           </p14:sldIdLst>
         </p14:section>
-        <p14:section name="Компетенции" id="{1b198af2-1d02-1573-2361-c3bae945c9e3}">
+        <p14:section name="Компетенции" id="{24a2e077-245b-707a-edc3-3889062d2f8d}">
           <p14:sldIdLst>
             <p14:sldId id="263"/>
             <p14:sldId id="264"/>
           </p14:sldIdLst>
         </p14:section>
-        <p14:section name="План и контакты" id="{85fb757b-bda2-e014-4280-bbf3648f365a}">
+        <p14:section name="План и контакты" id="{9478c98b-1869-28d4-2b9a-25aefc85d454}">
           <p14:sldIdLst>
             <p14:sldId id="265"/>
             <p14:sldId id="266"/>
@@ -1428,7 +1428,7 @@
           <a:p>
             <a:r>
               <a:rPr lang="en-US" dirty="0"/>
-              <a:t>Инструменты в квадратных скобках указаны предположительно: в резюме их нет. Оставить только те, которыми реально владеешь.</a:t>
+              <a:t/>
             </a:r>
             <a:endParaRPr lang="en-US" dirty="0"/>
           </a:p>
@@ -8063,7 +8063,7 @@
       </p:sp>
       <p:sp>
         <p:nvSpPr>
-          <p:cNvPr id="5" name="text-105"/>
+          <p:cNvPr id="4" name="text-105"/>
           <p:cNvSpPr txBox="1"/>
           <p:nvPr/>
         </p:nvSpPr>
@@ -8099,7 +8099,7 @@
       </p:sp>
       <p:sp>
         <p:nvSpPr>
-          <p:cNvPr id="6" name="pill-106"/>
+          <p:cNvPr id="5" name="pill-106"/>
           <p:cNvSpPr/>
           <p:nvPr/>
         </p:nvSpPr>
@@ -8121,7 +8121,7 @@
       </p:sp>
       <p:sp>
         <p:nvSpPr>
-          <p:cNvPr id="7" name="text-107"/>
+          <p:cNvPr id="6" name="text-107"/>
           <p:cNvSpPr txBox="1"/>
           <p:nvPr/>
         </p:nvSpPr>
@@ -8157,7 +8157,7 @@
       </p:sp>
       <p:sp>
         <p:nvSpPr>
-          <p:cNvPr id="8" name="pill-108"/>
+          <p:cNvPr id="7" name="pill-108"/>
           <p:cNvSpPr/>
           <p:nvPr/>
         </p:nvSpPr>
@@ -8179,7 +8179,7 @@
       </p:sp>
       <p:sp>
         <p:nvSpPr>
-          <p:cNvPr id="9" name="text-109"/>
+          <p:cNvPr id="8" name="text-109"/>
           <p:cNvSpPr txBox="1"/>
           <p:nvPr/>
         </p:nvSpPr>
@@ -8215,7 +8215,7 @@
       </p:sp>
       <p:sp>
         <p:nvSpPr>
-          <p:cNvPr id="10" name="pill-110"/>
+          <p:cNvPr id="9" name="pill-110"/>
           <p:cNvSpPr/>
           <p:nvPr/>
         </p:nvSpPr>
@@ -8237,7 +8237,7 @@
       </p:sp>
       <p:sp>
         <p:nvSpPr>
-          <p:cNvPr id="11" name="text-111"/>
+          <p:cNvPr id="10" name="text-111"/>
           <p:cNvSpPr txBox="1"/>
           <p:nvPr/>
         </p:nvSpPr>
@@ -8273,7 +8273,7 @@
       </p:sp>
       <p:sp>
         <p:nvSpPr>
-          <p:cNvPr id="12" name="pill-112"/>
+          <p:cNvPr id="11" name="pill-112"/>
           <p:cNvSpPr/>
           <p:nvPr/>
         </p:nvSpPr>
@@ -8295,7 +8295,7 @@
       </p:sp>
       <p:sp>
         <p:nvSpPr>
-          <p:cNvPr id="13" name="text-113"/>
+          <p:cNvPr id="12" name="text-113"/>
           <p:cNvSpPr txBox="1"/>
           <p:nvPr/>
         </p:nvSpPr>
@@ -8331,7 +8331,7 @@
       </p:sp>
       <p:sp>
         <p:nvSpPr>
-          <p:cNvPr id="14" name="pill-114"/>
+          <p:cNvPr id="13" name="pill-114"/>
           <p:cNvSpPr/>
           <p:nvPr/>
         </p:nvSpPr>
@@ -8353,7 +8353,7 @@
       </p:sp>
       <p:sp>
         <p:nvSpPr>
-          <p:cNvPr id="15" name="text-115"/>
+          <p:cNvPr id="14" name="text-115"/>
           <p:cNvSpPr txBox="1"/>
           <p:nvPr/>
         </p:nvSpPr>
@@ -8389,7 +8389,7 @@
       </p:sp>
       <p:sp>
         <p:nvSpPr>
-          <p:cNvPr id="16" name="pill-116"/>
+          <p:cNvPr id="15" name="pill-116"/>
           <p:cNvSpPr/>
           <p:nvPr/>
         </p:nvSpPr>
@@ -8411,7 +8411,7 @@
       </p:sp>
       <p:sp>
         <p:nvSpPr>
-          <p:cNvPr id="17" name="text-117"/>
+          <p:cNvPr id="16" name="text-117"/>
           <p:cNvSpPr txBox="1"/>
           <p:nvPr/>
         </p:nvSpPr>
@@ -8447,7 +8447,7 @@
       </p:sp>
       <p:sp>
         <p:nvSpPr>
-          <p:cNvPr id="18" name="text-118"/>
+          <p:cNvPr id="17" name="text-118"/>
           <p:cNvSpPr txBox="1"/>
           <p:nvPr/>
         </p:nvSpPr>
@@ -8483,7 +8483,7 @@
       </p:sp>
       <p:sp>
         <p:nvSpPr>
-          <p:cNvPr id="19" name="pill-119"/>
+          <p:cNvPr id="18" name="pill-119"/>
           <p:cNvSpPr/>
           <p:nvPr/>
         </p:nvSpPr>
@@ -8505,7 +8505,7 @@
       </p:sp>
       <p:sp>
         <p:nvSpPr>
-          <p:cNvPr id="20" name="text-120"/>
+          <p:cNvPr id="19" name="text-120"/>
           <p:cNvSpPr txBox="1"/>
           <p:nvPr/>
         </p:nvSpPr>
@@ -8541,14 +8541,14 @@
       </p:sp>
       <p:sp>
         <p:nvSpPr>
-          <p:cNvPr id="21" name="pill-121"/>
+          <p:cNvPr id="20" name="pill-121"/>
           <p:cNvSpPr/>
           <p:nvPr/>
         </p:nvSpPr>
         <p:spPr>
           <a:xfrm>
             <a:off x="3917950" y="3302000"/>
-            <a:ext cx="1016000" cy="381000"/>
+            <a:ext cx="850900" cy="381000"/>
           </a:xfrm>
           <a:prstGeom prst="roundRect">
             <a:avLst>
@@ -8563,14 +8563,14 @@
       </p:sp>
       <p:sp>
         <p:nvSpPr>
-          <p:cNvPr id="22" name="text-122"/>
+          <p:cNvPr id="21" name="text-122"/>
           <p:cNvSpPr txBox="1"/>
           <p:nvPr/>
         </p:nvSpPr>
         <p:spPr>
           <a:xfrm>
             <a:off x="3917950" y="3302000"/>
-            <a:ext cx="1016000" cy="381000"/>
+            <a:ext cx="850900" cy="381000"/>
           </a:xfrm>
           <a:prstGeom prst="rect">
             <a:avLst/>
@@ -8591,7 +8591,7 @@
                   <a:schemeClr val="accent3"/>
                 </a:solidFill>
               </a:rPr>
-              <a:t>[CapCut]</a:t>
+              <a:t>CapCut</a:t>
             </a:r>
             <a:endParaRPr lang="en-US" sz="1300" dirty="0"/>
           </a:p>
@@ -8599,14 +8599,14 @@
       </p:sp>
       <p:sp>
         <p:nvSpPr>
-          <p:cNvPr id="23" name="pill-123"/>
+          <p:cNvPr id="22" name="pill-123"/>
           <p:cNvSpPr/>
           <p:nvPr/>
         </p:nvSpPr>
         <p:spPr>
           <a:xfrm>
-            <a:off x="5035550" y="3302000"/>
-            <a:ext cx="933450" cy="381000"/>
+            <a:off x="4870450" y="3302000"/>
+            <a:ext cx="768350" cy="381000"/>
           </a:xfrm>
           <a:prstGeom prst="roundRect">
             <a:avLst>
@@ -8621,14 +8621,14 @@
       </p:sp>
       <p:sp>
         <p:nvSpPr>
-          <p:cNvPr id="24" name="text-124"/>
-          <p:cNvSpPr txBox="1"/>
-          <p:nvPr/>
-        </p:nvSpPr>
-        <p:spPr>
-          <a:xfrm>
-            <a:off x="5035550" y="3302000"/>
-            <a:ext cx="933450" cy="381000"/>
+          <p:cNvPr id="23" name="text-124"/>
+          <p:cNvSpPr txBox="1"/>
+          <p:nvPr/>
+        </p:nvSpPr>
+        <p:spPr>
+          <a:xfrm>
+            <a:off x="4870450" y="3302000"/>
+            <a:ext cx="768350" cy="381000"/>
           </a:xfrm>
           <a:prstGeom prst="rect">
             <a:avLst/>
@@ -8649,7 +8649,7 @@
                   <a:schemeClr val="accent3"/>
                 </a:solidFill>
               </a:rPr>
-              <a:t>[Canva]</a:t>
+              <a:t>Canva</a:t>
             </a:r>
             <a:endParaRPr lang="en-US" sz="1300" dirty="0"/>
           </a:p>
@@ -8657,14 +8657,14 @@
       </p:sp>
       <p:sp>
         <p:nvSpPr>
-          <p:cNvPr id="25" name="pill-125"/>
+          <p:cNvPr id="24" name="pill-125"/>
           <p:cNvSpPr/>
           <p:nvPr/>
         </p:nvSpPr>
         <p:spPr>
           <a:xfrm>
-            <a:off x="6070600" y="3302000"/>
-            <a:ext cx="1924050" cy="381000"/>
+            <a:off x="5740400" y="3302000"/>
+            <a:ext cx="1758950" cy="381000"/>
           </a:xfrm>
           <a:prstGeom prst="roundRect">
             <a:avLst>
@@ -8679,14 +8679,14 @@
       </p:sp>
       <p:sp>
         <p:nvSpPr>
-          <p:cNvPr id="26" name="text-126"/>
-          <p:cNvSpPr txBox="1"/>
-          <p:nvPr/>
-        </p:nvSpPr>
-        <p:spPr>
-          <a:xfrm>
-            <a:off x="6070600" y="3302000"/>
-            <a:ext cx="1924050" cy="381000"/>
+          <p:cNvPr id="25" name="text-126"/>
+          <p:cNvSpPr txBox="1"/>
+          <p:nvPr/>
+        </p:nvSpPr>
+        <p:spPr>
+          <a:xfrm>
+            <a:off x="5740400" y="3302000"/>
+            <a:ext cx="1758950" cy="381000"/>
           </a:xfrm>
           <a:prstGeom prst="rect">
             <a:avLst/>
@@ -8707,7 +8707,7 @@
                   <a:schemeClr val="accent3"/>
                 </a:solidFill>
               </a:rPr>
-              <a:t>[Premiere / InShot]</a:t>
+              <a:t>Premiere / InShot</a:t>
             </a:r>
             <a:endParaRPr lang="en-US" sz="1300" dirty="0"/>
           </a:p>
@@ -8715,7 +8715,7 @@
       </p:sp>
       <p:sp>
         <p:nvSpPr>
-          <p:cNvPr id="27" name="text-127"/>
+          <p:cNvPr id="26" name="text-127"/>
           <p:cNvSpPr txBox="1"/>
           <p:nvPr/>
         </p:nvSpPr>
@@ -8751,7 +8751,7 @@
       </p:sp>
       <p:sp>
         <p:nvSpPr>
-          <p:cNvPr id="28" name="pill-128"/>
+          <p:cNvPr id="27" name="pill-128"/>
           <p:cNvSpPr/>
           <p:nvPr/>
         </p:nvSpPr>
@@ -8775,7 +8775,7 @@
       </p:sp>
       <p:sp>
         <p:nvSpPr>
-          <p:cNvPr id="29" name="text-129"/>
+          <p:cNvPr id="28" name="text-129"/>
           <p:cNvSpPr txBox="1"/>
           <p:nvPr/>
         </p:nvSpPr>
@@ -8811,7 +8811,7 @@
       </p:sp>
       <p:sp>
         <p:nvSpPr>
-          <p:cNvPr id="30" name="pill-130"/>
+          <p:cNvPr id="29" name="pill-130"/>
           <p:cNvSpPr/>
           <p:nvPr/>
         </p:nvSpPr>
@@ -8835,7 +8835,7 @@
       </p:sp>
       <p:sp>
         <p:nvSpPr>
-          <p:cNvPr id="31" name="text-131"/>
+          <p:cNvPr id="30" name="text-131"/>
           <p:cNvSpPr txBox="1"/>
           <p:nvPr/>
         </p:nvSpPr>
@@ -8871,7 +8871,7 @@
       </p:sp>
       <p:sp>
         <p:nvSpPr>
-          <p:cNvPr id="32" name="pill-132"/>
+          <p:cNvPr id="31" name="pill-132"/>
           <p:cNvSpPr/>
           <p:nvPr/>
         </p:nvSpPr>
@@ -8895,7 +8895,7 @@
       </p:sp>
       <p:sp>
         <p:nvSpPr>
-          <p:cNvPr id="33" name="text-133"/>
+          <p:cNvPr id="32" name="text-133"/>
           <p:cNvSpPr txBox="1"/>
           <p:nvPr/>
         </p:nvSpPr>
@@ -8931,7 +8931,7 @@
       </p:sp>
       <p:sp>
         <p:nvSpPr>
-          <p:cNvPr id="34" name="pill-134"/>
+          <p:cNvPr id="33" name="pill-134"/>
           <p:cNvSpPr/>
           <p:nvPr/>
         </p:nvSpPr>
@@ -8955,7 +8955,7 @@
       </p:sp>
       <p:sp>
         <p:nvSpPr>
-          <p:cNvPr id="35" name="text-135"/>
+          <p:cNvPr id="34" name="text-135"/>
           <p:cNvSpPr txBox="1"/>
           <p:nvPr/>
         </p:nvSpPr>
@@ -8991,7 +8991,7 @@
       </p:sp>
       <p:sp>
         <p:nvSpPr>
-          <p:cNvPr id="36" name="pill-136"/>
+          <p:cNvPr id="35" name="pill-136"/>
           <p:cNvSpPr/>
           <p:nvPr/>
         </p:nvSpPr>
@@ -9015,7 +9015,7 @@
       </p:sp>
       <p:sp>
         <p:nvSpPr>
-          <p:cNvPr id="37" name="text-137"/>
+          <p:cNvPr id="36" name="text-137"/>
           <p:cNvSpPr txBox="1"/>
           <p:nvPr/>
         </p:nvSpPr>
@@ -9051,7 +9051,7 @@
       </p:sp>
       <p:sp>
         <p:nvSpPr>
-          <p:cNvPr id="38" name="pill-138"/>
+          <p:cNvPr id="37" name="pill-138"/>
           <p:cNvSpPr/>
           <p:nvPr/>
         </p:nvSpPr>
@@ -9075,7 +9075,7 @@
       </p:sp>
       <p:sp>
         <p:nvSpPr>
-          <p:cNvPr id="39" name="text-139"/>
+          <p:cNvPr id="38" name="text-139"/>
           <p:cNvSpPr txBox="1"/>
           <p:nvPr/>
         </p:nvSpPr>
@@ -9111,7 +9111,7 @@
       </p:sp>
       <p:sp>
         <p:nvSpPr>
-          <p:cNvPr id="40" name="pill-140"/>
+          <p:cNvPr id="39" name="pill-140"/>
           <p:cNvSpPr/>
           <p:nvPr/>
         </p:nvSpPr>
@@ -9135,7 +9135,7 @@
       </p:sp>
       <p:sp>
         <p:nvSpPr>
-          <p:cNvPr id="41" name="text-141"/>
+          <p:cNvPr id="40" name="text-141"/>
           <p:cNvSpPr txBox="1"/>
           <p:nvPr/>
         </p:nvSpPr>

</xml_diff>